<commit_message>
Update presentation guides with Engagement labels and klo-app.vercel.app URLs
Co-Authored-By: Claude Opus 4.6 <noreply@anthropic.com>
</commit_message>
<xml_diff>
--- a/public/conference-v2-guide.pptx
+++ b/public/conference-v2-guide.pptx
@@ -2116,7 +2116,7 @@
       </p:grpSpPr>
       <p:pic>
         <p:nvPicPr>
-          <p:cNvPr id="2" name="Image 0" descr="/tmp/conf-guide-slides/slide-01.png">    </p:cNvPr>
+          <p:cNvPr id="2" name="Image 0" descr="preencoded.png">    </p:cNvPr>
           <p:cNvPicPr>
             <a:picLocks noChangeAspect="1"/>
           </p:cNvPicPr>
@@ -2131,7 +2131,7 @@
         <p:spPr>
           <a:xfrm>
             <a:off x="0" y="0"/>
-            <a:ext cx="9144000" cy="5148072"/>
+            <a:ext cx="9144000" cy="5143500"/>
           </a:xfrm>
           <a:prstGeom prst="rect">
             <a:avLst/>
@@ -2165,7 +2165,7 @@
       </p:grpSpPr>
       <p:pic>
         <p:nvPicPr>
-          <p:cNvPr id="2" name="Image 0" descr="/tmp/conf-guide-slides/slide-10.png">    </p:cNvPr>
+          <p:cNvPr id="2" name="Image 0" descr="preencoded.png">    </p:cNvPr>
           <p:cNvPicPr>
             <a:picLocks noChangeAspect="1"/>
           </p:cNvPicPr>
@@ -2180,7 +2180,7 @@
         <p:spPr>
           <a:xfrm>
             <a:off x="0" y="0"/>
-            <a:ext cx="9144000" cy="5148072"/>
+            <a:ext cx="9144000" cy="5143500"/>
           </a:xfrm>
           <a:prstGeom prst="rect">
             <a:avLst/>
@@ -2214,7 +2214,7 @@
       </p:grpSpPr>
       <p:pic>
         <p:nvPicPr>
-          <p:cNvPr id="2" name="Image 0" descr="/tmp/conf-guide-slides/slide-11.png">    </p:cNvPr>
+          <p:cNvPr id="2" name="Image 0" descr="preencoded.png">    </p:cNvPr>
           <p:cNvPicPr>
             <a:picLocks noChangeAspect="1"/>
           </p:cNvPicPr>
@@ -2229,7 +2229,7 @@
         <p:spPr>
           <a:xfrm>
             <a:off x="0" y="0"/>
-            <a:ext cx="9144000" cy="5148072"/>
+            <a:ext cx="9144000" cy="5143500"/>
           </a:xfrm>
           <a:prstGeom prst="rect">
             <a:avLst/>
@@ -2263,7 +2263,7 @@
       </p:grpSpPr>
       <p:pic>
         <p:nvPicPr>
-          <p:cNvPr id="2" name="Image 0" descr="/tmp/conf-guide-slides/slide-12.png">    </p:cNvPr>
+          <p:cNvPr id="2" name="Image 0" descr="preencoded.png">    </p:cNvPr>
           <p:cNvPicPr>
             <a:picLocks noChangeAspect="1"/>
           </p:cNvPicPr>
@@ -2278,7 +2278,7 @@
         <p:spPr>
           <a:xfrm>
             <a:off x="0" y="0"/>
-            <a:ext cx="9144000" cy="5148072"/>
+            <a:ext cx="9144000" cy="5143500"/>
           </a:xfrm>
           <a:prstGeom prst="rect">
             <a:avLst/>
@@ -2312,7 +2312,7 @@
       </p:grpSpPr>
       <p:pic>
         <p:nvPicPr>
-          <p:cNvPr id="2" name="Image 0" descr="/tmp/conf-guide-slides/slide-13.png">    </p:cNvPr>
+          <p:cNvPr id="2" name="Image 0" descr="preencoded.png">    </p:cNvPr>
           <p:cNvPicPr>
             <a:picLocks noChangeAspect="1"/>
           </p:cNvPicPr>
@@ -2327,7 +2327,7 @@
         <p:spPr>
           <a:xfrm>
             <a:off x="0" y="0"/>
-            <a:ext cx="9144000" cy="5148072"/>
+            <a:ext cx="9144000" cy="5143500"/>
           </a:xfrm>
           <a:prstGeom prst="rect">
             <a:avLst/>
@@ -2361,7 +2361,7 @@
       </p:grpSpPr>
       <p:pic>
         <p:nvPicPr>
-          <p:cNvPr id="2" name="Image 0" descr="/tmp/conf-guide-slides/slide-14.png">    </p:cNvPr>
+          <p:cNvPr id="2" name="Image 0" descr="preencoded.png">    </p:cNvPr>
           <p:cNvPicPr>
             <a:picLocks noChangeAspect="1"/>
           </p:cNvPicPr>
@@ -2376,7 +2376,7 @@
         <p:spPr>
           <a:xfrm>
             <a:off x="0" y="0"/>
-            <a:ext cx="9144000" cy="5148072"/>
+            <a:ext cx="9144000" cy="5143500"/>
           </a:xfrm>
           <a:prstGeom prst="rect">
             <a:avLst/>
@@ -2410,7 +2410,7 @@
       </p:grpSpPr>
       <p:pic>
         <p:nvPicPr>
-          <p:cNvPr id="2" name="Image 0" descr="/tmp/conf-guide-slides/slide-15.png">    </p:cNvPr>
+          <p:cNvPr id="2" name="Image 0" descr="preencoded.png">    </p:cNvPr>
           <p:cNvPicPr>
             <a:picLocks noChangeAspect="1"/>
           </p:cNvPicPr>
@@ -2425,7 +2425,7 @@
         <p:spPr>
           <a:xfrm>
             <a:off x="0" y="0"/>
-            <a:ext cx="9144000" cy="5148072"/>
+            <a:ext cx="9144000" cy="5143500"/>
           </a:xfrm>
           <a:prstGeom prst="rect">
             <a:avLst/>
@@ -2459,7 +2459,7 @@
       </p:grpSpPr>
       <p:pic>
         <p:nvPicPr>
-          <p:cNvPr id="2" name="Image 0" descr="/tmp/conf-guide-slides/slide-02.png">    </p:cNvPr>
+          <p:cNvPr id="2" name="Image 0" descr="preencoded.png">    </p:cNvPr>
           <p:cNvPicPr>
             <a:picLocks noChangeAspect="1"/>
           </p:cNvPicPr>
@@ -2474,7 +2474,7 @@
         <p:spPr>
           <a:xfrm>
             <a:off x="0" y="0"/>
-            <a:ext cx="9144000" cy="5148072"/>
+            <a:ext cx="9144000" cy="5143500"/>
           </a:xfrm>
           <a:prstGeom prst="rect">
             <a:avLst/>
@@ -2508,7 +2508,7 @@
       </p:grpSpPr>
       <p:pic>
         <p:nvPicPr>
-          <p:cNvPr id="2" name="Image 0" descr="/tmp/conf-guide-slides/slide-03.png">    </p:cNvPr>
+          <p:cNvPr id="2" name="Image 0" descr="preencoded.png">    </p:cNvPr>
           <p:cNvPicPr>
             <a:picLocks noChangeAspect="1"/>
           </p:cNvPicPr>
@@ -2523,7 +2523,7 @@
         <p:spPr>
           <a:xfrm>
             <a:off x="0" y="0"/>
-            <a:ext cx="9144000" cy="5148072"/>
+            <a:ext cx="9144000" cy="5143500"/>
           </a:xfrm>
           <a:prstGeom prst="rect">
             <a:avLst/>
@@ -2557,7 +2557,7 @@
       </p:grpSpPr>
       <p:pic>
         <p:nvPicPr>
-          <p:cNvPr id="2" name="Image 0" descr="/tmp/conf-guide-slides/slide-04.png">    </p:cNvPr>
+          <p:cNvPr id="2" name="Image 0" descr="preencoded.png">    </p:cNvPr>
           <p:cNvPicPr>
             <a:picLocks noChangeAspect="1"/>
           </p:cNvPicPr>
@@ -2572,7 +2572,7 @@
         <p:spPr>
           <a:xfrm>
             <a:off x="0" y="0"/>
-            <a:ext cx="9144000" cy="5148072"/>
+            <a:ext cx="9144000" cy="5143500"/>
           </a:xfrm>
           <a:prstGeom prst="rect">
             <a:avLst/>
@@ -2606,7 +2606,7 @@
       </p:grpSpPr>
       <p:pic>
         <p:nvPicPr>
-          <p:cNvPr id="2" name="Image 0" descr="/tmp/conf-guide-slides/slide-05.png">    </p:cNvPr>
+          <p:cNvPr id="2" name="Image 0" descr="preencoded.png">    </p:cNvPr>
           <p:cNvPicPr>
             <a:picLocks noChangeAspect="1"/>
           </p:cNvPicPr>
@@ -2621,7 +2621,7 @@
         <p:spPr>
           <a:xfrm>
             <a:off x="0" y="0"/>
-            <a:ext cx="9144000" cy="5148072"/>
+            <a:ext cx="9144000" cy="5143500"/>
           </a:xfrm>
           <a:prstGeom prst="rect">
             <a:avLst/>
@@ -2655,7 +2655,7 @@
       </p:grpSpPr>
       <p:pic>
         <p:nvPicPr>
-          <p:cNvPr id="2" name="Image 0" descr="/tmp/conf-guide-slides/slide-06.png">    </p:cNvPr>
+          <p:cNvPr id="2" name="Image 0" descr="preencoded.png">    </p:cNvPr>
           <p:cNvPicPr>
             <a:picLocks noChangeAspect="1"/>
           </p:cNvPicPr>
@@ -2670,7 +2670,7 @@
         <p:spPr>
           <a:xfrm>
             <a:off x="0" y="0"/>
-            <a:ext cx="9144000" cy="5148072"/>
+            <a:ext cx="9144000" cy="5143500"/>
           </a:xfrm>
           <a:prstGeom prst="rect">
             <a:avLst/>
@@ -2704,7 +2704,7 @@
       </p:grpSpPr>
       <p:pic>
         <p:nvPicPr>
-          <p:cNvPr id="2" name="Image 0" descr="/tmp/conf-guide-slides/slide-07.png">    </p:cNvPr>
+          <p:cNvPr id="2" name="Image 0" descr="preencoded.png">    </p:cNvPr>
           <p:cNvPicPr>
             <a:picLocks noChangeAspect="1"/>
           </p:cNvPicPr>
@@ -2719,7 +2719,7 @@
         <p:spPr>
           <a:xfrm>
             <a:off x="0" y="0"/>
-            <a:ext cx="9144000" cy="5148072"/>
+            <a:ext cx="9144000" cy="5143500"/>
           </a:xfrm>
           <a:prstGeom prst="rect">
             <a:avLst/>
@@ -2753,7 +2753,7 @@
       </p:grpSpPr>
       <p:pic>
         <p:nvPicPr>
-          <p:cNvPr id="2" name="Image 0" descr="/tmp/conf-guide-slides/slide-08.png">    </p:cNvPr>
+          <p:cNvPr id="2" name="Image 0" descr="preencoded.png">    </p:cNvPr>
           <p:cNvPicPr>
             <a:picLocks noChangeAspect="1"/>
           </p:cNvPicPr>
@@ -2768,7 +2768,7 @@
         <p:spPr>
           <a:xfrm>
             <a:off x="0" y="0"/>
-            <a:ext cx="9144000" cy="5148072"/>
+            <a:ext cx="9144000" cy="5143500"/>
           </a:xfrm>
           <a:prstGeom prst="rect">
             <a:avLst/>
@@ -2802,7 +2802,7 @@
       </p:grpSpPr>
       <p:pic>
         <p:nvPicPr>
-          <p:cNvPr id="2" name="Image 0" descr="/tmp/conf-guide-slides/slide-09.png">    </p:cNvPr>
+          <p:cNvPr id="2" name="Image 0" descr="preencoded.png">    </p:cNvPr>
           <p:cNvPicPr>
             <a:picLocks noChangeAspect="1"/>
           </p:cNvPicPr>
@@ -2817,7 +2817,7 @@
         <p:spPr>
           <a:xfrm>
             <a:off x="0" y="0"/>
-            <a:ext cx="9144000" cy="5148072"/>
+            <a:ext cx="9144000" cy="5143500"/>
           </a:xfrm>
           <a:prstGeom prst="rect">
             <a:avLst/>

</xml_diff>

<commit_message>
Update presentations: shared WiFi voting, vault featured content, v2.2
- Platform Guide: featured keynote on Events, vault highlights Moral Frontier
  briefing, shared WiFi voting note on polls and attendee quick start
- Conference V2 Guide: bump to v2.2, shared WiFi voting, 100+ user
  optimization highlights, remove old profanity/archive bullets
- Both PPTX files regenerated from updated HTML

Co-Authored-By: Claude Opus 4.6 <noreply@anthropic.com>
</commit_message>
<xml_diff>
--- a/public/conference-v2-guide.pptx
+++ b/public/conference-v2-guide.pptx
@@ -2116,7 +2116,7 @@
       </p:grpSpPr>
       <p:pic>
         <p:nvPicPr>
-          <p:cNvPr id="2" name="Image 0" descr="preencoded.png">    </p:cNvPr>
+          <p:cNvPr id="2" name="Image 0" descr="/tmp/slide-screenshots/slide-001.png">    </p:cNvPr>
           <p:cNvPicPr>
             <a:picLocks noChangeAspect="1"/>
           </p:cNvPicPr>
@@ -2131,7 +2131,7 @@
         <p:spPr>
           <a:xfrm>
             <a:off x="0" y="0"/>
-            <a:ext cx="9144000" cy="5143500"/>
+            <a:ext cx="9144000" cy="5148072"/>
           </a:xfrm>
           <a:prstGeom prst="rect">
             <a:avLst/>
@@ -2165,7 +2165,7 @@
       </p:grpSpPr>
       <p:pic>
         <p:nvPicPr>
-          <p:cNvPr id="2" name="Image 0" descr="preencoded.png">    </p:cNvPr>
+          <p:cNvPr id="2" name="Image 0" descr="/tmp/slide-screenshots/slide-010.png">    </p:cNvPr>
           <p:cNvPicPr>
             <a:picLocks noChangeAspect="1"/>
           </p:cNvPicPr>
@@ -2180,7 +2180,7 @@
         <p:spPr>
           <a:xfrm>
             <a:off x="0" y="0"/>
-            <a:ext cx="9144000" cy="5143500"/>
+            <a:ext cx="9144000" cy="5148072"/>
           </a:xfrm>
           <a:prstGeom prst="rect">
             <a:avLst/>
@@ -2214,7 +2214,7 @@
       </p:grpSpPr>
       <p:pic>
         <p:nvPicPr>
-          <p:cNvPr id="2" name="Image 0" descr="preencoded.png">    </p:cNvPr>
+          <p:cNvPr id="2" name="Image 0" descr="/tmp/slide-screenshots/slide-011.png">    </p:cNvPr>
           <p:cNvPicPr>
             <a:picLocks noChangeAspect="1"/>
           </p:cNvPicPr>
@@ -2229,7 +2229,7 @@
         <p:spPr>
           <a:xfrm>
             <a:off x="0" y="0"/>
-            <a:ext cx="9144000" cy="5143500"/>
+            <a:ext cx="9144000" cy="5148072"/>
           </a:xfrm>
           <a:prstGeom prst="rect">
             <a:avLst/>
@@ -2263,7 +2263,7 @@
       </p:grpSpPr>
       <p:pic>
         <p:nvPicPr>
-          <p:cNvPr id="2" name="Image 0" descr="preencoded.png">    </p:cNvPr>
+          <p:cNvPr id="2" name="Image 0" descr="/tmp/slide-screenshots/slide-012.png">    </p:cNvPr>
           <p:cNvPicPr>
             <a:picLocks noChangeAspect="1"/>
           </p:cNvPicPr>
@@ -2278,7 +2278,7 @@
         <p:spPr>
           <a:xfrm>
             <a:off x="0" y="0"/>
-            <a:ext cx="9144000" cy="5143500"/>
+            <a:ext cx="9144000" cy="5148072"/>
           </a:xfrm>
           <a:prstGeom prst="rect">
             <a:avLst/>
@@ -2312,7 +2312,7 @@
       </p:grpSpPr>
       <p:pic>
         <p:nvPicPr>
-          <p:cNvPr id="2" name="Image 0" descr="preencoded.png">    </p:cNvPr>
+          <p:cNvPr id="2" name="Image 0" descr="/tmp/slide-screenshots/slide-013.png">    </p:cNvPr>
           <p:cNvPicPr>
             <a:picLocks noChangeAspect="1"/>
           </p:cNvPicPr>
@@ -2327,7 +2327,7 @@
         <p:spPr>
           <a:xfrm>
             <a:off x="0" y="0"/>
-            <a:ext cx="9144000" cy="5143500"/>
+            <a:ext cx="9144000" cy="5148072"/>
           </a:xfrm>
           <a:prstGeom prst="rect">
             <a:avLst/>
@@ -2361,7 +2361,7 @@
       </p:grpSpPr>
       <p:pic>
         <p:nvPicPr>
-          <p:cNvPr id="2" name="Image 0" descr="preencoded.png">    </p:cNvPr>
+          <p:cNvPr id="2" name="Image 0" descr="/tmp/slide-screenshots/slide-014.png">    </p:cNvPr>
           <p:cNvPicPr>
             <a:picLocks noChangeAspect="1"/>
           </p:cNvPicPr>
@@ -2376,7 +2376,7 @@
         <p:spPr>
           <a:xfrm>
             <a:off x="0" y="0"/>
-            <a:ext cx="9144000" cy="5143500"/>
+            <a:ext cx="9144000" cy="5148072"/>
           </a:xfrm>
           <a:prstGeom prst="rect">
             <a:avLst/>
@@ -2410,7 +2410,7 @@
       </p:grpSpPr>
       <p:pic>
         <p:nvPicPr>
-          <p:cNvPr id="2" name="Image 0" descr="preencoded.png">    </p:cNvPr>
+          <p:cNvPr id="2" name="Image 0" descr="/tmp/slide-screenshots/slide-015.png">    </p:cNvPr>
           <p:cNvPicPr>
             <a:picLocks noChangeAspect="1"/>
           </p:cNvPicPr>
@@ -2425,7 +2425,7 @@
         <p:spPr>
           <a:xfrm>
             <a:off x="0" y="0"/>
-            <a:ext cx="9144000" cy="5143500"/>
+            <a:ext cx="9144000" cy="5148072"/>
           </a:xfrm>
           <a:prstGeom prst="rect">
             <a:avLst/>
@@ -2459,7 +2459,7 @@
       </p:grpSpPr>
       <p:pic>
         <p:nvPicPr>
-          <p:cNvPr id="2" name="Image 0" descr="preencoded.png">    </p:cNvPr>
+          <p:cNvPr id="2" name="Image 0" descr="/tmp/slide-screenshots/slide-002.png">    </p:cNvPr>
           <p:cNvPicPr>
             <a:picLocks noChangeAspect="1"/>
           </p:cNvPicPr>
@@ -2474,7 +2474,7 @@
         <p:spPr>
           <a:xfrm>
             <a:off x="0" y="0"/>
-            <a:ext cx="9144000" cy="5143500"/>
+            <a:ext cx="9144000" cy="5148072"/>
           </a:xfrm>
           <a:prstGeom prst="rect">
             <a:avLst/>
@@ -2508,7 +2508,7 @@
       </p:grpSpPr>
       <p:pic>
         <p:nvPicPr>
-          <p:cNvPr id="2" name="Image 0" descr="preencoded.png">    </p:cNvPr>
+          <p:cNvPr id="2" name="Image 0" descr="/tmp/slide-screenshots/slide-003.png">    </p:cNvPr>
           <p:cNvPicPr>
             <a:picLocks noChangeAspect="1"/>
           </p:cNvPicPr>
@@ -2523,7 +2523,7 @@
         <p:spPr>
           <a:xfrm>
             <a:off x="0" y="0"/>
-            <a:ext cx="9144000" cy="5143500"/>
+            <a:ext cx="9144000" cy="5148072"/>
           </a:xfrm>
           <a:prstGeom prst="rect">
             <a:avLst/>
@@ -2557,7 +2557,7 @@
       </p:grpSpPr>
       <p:pic>
         <p:nvPicPr>
-          <p:cNvPr id="2" name="Image 0" descr="preencoded.png">    </p:cNvPr>
+          <p:cNvPr id="2" name="Image 0" descr="/tmp/slide-screenshots/slide-004.png">    </p:cNvPr>
           <p:cNvPicPr>
             <a:picLocks noChangeAspect="1"/>
           </p:cNvPicPr>
@@ -2572,7 +2572,7 @@
         <p:spPr>
           <a:xfrm>
             <a:off x="0" y="0"/>
-            <a:ext cx="9144000" cy="5143500"/>
+            <a:ext cx="9144000" cy="5148072"/>
           </a:xfrm>
           <a:prstGeom prst="rect">
             <a:avLst/>
@@ -2606,7 +2606,7 @@
       </p:grpSpPr>
       <p:pic>
         <p:nvPicPr>
-          <p:cNvPr id="2" name="Image 0" descr="preencoded.png">    </p:cNvPr>
+          <p:cNvPr id="2" name="Image 0" descr="/tmp/slide-screenshots/slide-005.png">    </p:cNvPr>
           <p:cNvPicPr>
             <a:picLocks noChangeAspect="1"/>
           </p:cNvPicPr>
@@ -2621,7 +2621,7 @@
         <p:spPr>
           <a:xfrm>
             <a:off x="0" y="0"/>
-            <a:ext cx="9144000" cy="5143500"/>
+            <a:ext cx="9144000" cy="5148072"/>
           </a:xfrm>
           <a:prstGeom prst="rect">
             <a:avLst/>
@@ -2655,7 +2655,7 @@
       </p:grpSpPr>
       <p:pic>
         <p:nvPicPr>
-          <p:cNvPr id="2" name="Image 0" descr="preencoded.png">    </p:cNvPr>
+          <p:cNvPr id="2" name="Image 0" descr="/tmp/slide-screenshots/slide-006.png">    </p:cNvPr>
           <p:cNvPicPr>
             <a:picLocks noChangeAspect="1"/>
           </p:cNvPicPr>
@@ -2670,7 +2670,7 @@
         <p:spPr>
           <a:xfrm>
             <a:off x="0" y="0"/>
-            <a:ext cx="9144000" cy="5143500"/>
+            <a:ext cx="9144000" cy="5148072"/>
           </a:xfrm>
           <a:prstGeom prst="rect">
             <a:avLst/>
@@ -2704,7 +2704,7 @@
       </p:grpSpPr>
       <p:pic>
         <p:nvPicPr>
-          <p:cNvPr id="2" name="Image 0" descr="preencoded.png">    </p:cNvPr>
+          <p:cNvPr id="2" name="Image 0" descr="/tmp/slide-screenshots/slide-007.png">    </p:cNvPr>
           <p:cNvPicPr>
             <a:picLocks noChangeAspect="1"/>
           </p:cNvPicPr>
@@ -2719,7 +2719,7 @@
         <p:spPr>
           <a:xfrm>
             <a:off x="0" y="0"/>
-            <a:ext cx="9144000" cy="5143500"/>
+            <a:ext cx="9144000" cy="5148072"/>
           </a:xfrm>
           <a:prstGeom prst="rect">
             <a:avLst/>
@@ -2753,7 +2753,7 @@
       </p:grpSpPr>
       <p:pic>
         <p:nvPicPr>
-          <p:cNvPr id="2" name="Image 0" descr="preencoded.png">    </p:cNvPr>
+          <p:cNvPr id="2" name="Image 0" descr="/tmp/slide-screenshots/slide-008.png">    </p:cNvPr>
           <p:cNvPicPr>
             <a:picLocks noChangeAspect="1"/>
           </p:cNvPicPr>
@@ -2768,7 +2768,7 @@
         <p:spPr>
           <a:xfrm>
             <a:off x="0" y="0"/>
-            <a:ext cx="9144000" cy="5143500"/>
+            <a:ext cx="9144000" cy="5148072"/>
           </a:xfrm>
           <a:prstGeom prst="rect">
             <a:avLst/>
@@ -2802,7 +2802,7 @@
       </p:grpSpPr>
       <p:pic>
         <p:nvPicPr>
-          <p:cNvPr id="2" name="Image 0" descr="preencoded.png">    </p:cNvPr>
+          <p:cNvPr id="2" name="Image 0" descr="/tmp/slide-screenshots/slide-009.png">    </p:cNvPr>
           <p:cNvPicPr>
             <a:picLocks noChangeAspect="1"/>
           </p:cNvPicPr>
@@ -2817,7 +2817,7 @@
         <p:spPr>
           <a:xfrm>
             <a:off x="0" y="0"/>
-            <a:ext cx="9144000" cy="5143500"/>
+            <a:ext cx="9144000" cy="5148072"/>
           </a:xfrm>
           <a:prstGeom prst="rect">
             <a:avLst/>

</xml_diff>